<commit_message>
log-loss and softmax changes
</commit_message>
<xml_diff>
--- a/Model_evaluation.pptx
+++ b/Model_evaluation.pptx
@@ -12,8 +12,8 @@
     <p:sldId id="259" r:id="rId3"/>
     <p:sldId id="344" r:id="rId4"/>
     <p:sldId id="260" r:id="rId5"/>
-    <p:sldId id="263" r:id="rId6"/>
-    <p:sldId id="331" r:id="rId7"/>
+    <p:sldId id="345" r:id="rId6"/>
+    <p:sldId id="267" r:id="rId7"/>
     <p:sldId id="261" r:id="rId8"/>
     <p:sldId id="262" r:id="rId9"/>
     <p:sldId id="333" r:id="rId10"/>
@@ -384,7 +384,7 @@
           <a:p>
             <a:fld id="{04D9749C-2D9B-954A-94CA-5C7085E505E4}" type="datetimeFigureOut">
               <a:rPr lang="en-US" smtClean="0"/>
-              <a:t>10/10/19</a:t>
+              <a:t>1/8/20</a:t>
             </a:fld>
             <a:endParaRPr lang="en-US"/>
           </a:p>
@@ -968,7 +968,7 @@
     </p:spTree>
     <p:extLst>
       <p:ext uri="{BB962C8B-B14F-4D97-AF65-F5344CB8AC3E}">
-        <p14:creationId xmlns:p14="http://schemas.microsoft.com/office/powerpoint/2010/main" val="3110097261"/>
+        <p14:creationId xmlns:p14="http://schemas.microsoft.com/office/powerpoint/2010/main" val="4171618270"/>
       </p:ext>
     </p:extLst>
   </p:cSld>
@@ -1670,7 +1670,7 @@
           <a:p>
             <a:fld id="{A9942DAA-FFA8-C840-B5B2-5C2E91E85358}" type="datetimeFigureOut">
               <a:rPr lang="en-US" smtClean="0"/>
-              <a:t>10/10/19</a:t>
+              <a:t>1/8/20</a:t>
             </a:fld>
             <a:endParaRPr lang="en-US"/>
           </a:p>
@@ -1868,7 +1868,7 @@
           <a:p>
             <a:fld id="{A9942DAA-FFA8-C840-B5B2-5C2E91E85358}" type="datetimeFigureOut">
               <a:rPr lang="en-US" smtClean="0"/>
-              <a:t>10/10/19</a:t>
+              <a:t>1/8/20</a:t>
             </a:fld>
             <a:endParaRPr lang="en-US"/>
           </a:p>
@@ -2076,7 +2076,7 @@
           <a:p>
             <a:fld id="{A9942DAA-FFA8-C840-B5B2-5C2E91E85358}" type="datetimeFigureOut">
               <a:rPr lang="en-US" smtClean="0"/>
-              <a:t>10/10/19</a:t>
+              <a:t>1/8/20</a:t>
             </a:fld>
             <a:endParaRPr lang="en-US"/>
           </a:p>
@@ -2274,7 +2274,7 @@
           <a:p>
             <a:fld id="{A9942DAA-FFA8-C840-B5B2-5C2E91E85358}" type="datetimeFigureOut">
               <a:rPr lang="en-US" smtClean="0"/>
-              <a:t>10/10/19</a:t>
+              <a:t>1/8/20</a:t>
             </a:fld>
             <a:endParaRPr lang="en-US"/>
           </a:p>
@@ -2549,7 +2549,7 @@
           <a:p>
             <a:fld id="{A9942DAA-FFA8-C840-B5B2-5C2E91E85358}" type="datetimeFigureOut">
               <a:rPr lang="en-US" smtClean="0"/>
-              <a:t>10/10/19</a:t>
+              <a:t>1/8/20</a:t>
             </a:fld>
             <a:endParaRPr lang="en-US"/>
           </a:p>
@@ -2814,7 +2814,7 @@
           <a:p>
             <a:fld id="{A9942DAA-FFA8-C840-B5B2-5C2E91E85358}" type="datetimeFigureOut">
               <a:rPr lang="en-US" smtClean="0"/>
-              <a:t>10/10/19</a:t>
+              <a:t>1/8/20</a:t>
             </a:fld>
             <a:endParaRPr lang="en-US"/>
           </a:p>
@@ -3226,7 +3226,7 @@
           <a:p>
             <a:fld id="{A9942DAA-FFA8-C840-B5B2-5C2E91E85358}" type="datetimeFigureOut">
               <a:rPr lang="en-US" smtClean="0"/>
-              <a:t>10/10/19</a:t>
+              <a:t>1/8/20</a:t>
             </a:fld>
             <a:endParaRPr lang="en-US"/>
           </a:p>
@@ -3367,7 +3367,7 @@
           <a:p>
             <a:fld id="{A9942DAA-FFA8-C840-B5B2-5C2E91E85358}" type="datetimeFigureOut">
               <a:rPr lang="en-US" smtClean="0"/>
-              <a:t>10/10/19</a:t>
+              <a:t>1/8/20</a:t>
             </a:fld>
             <a:endParaRPr lang="en-US"/>
           </a:p>
@@ -3480,7 +3480,7 @@
           <a:p>
             <a:fld id="{A9942DAA-FFA8-C840-B5B2-5C2E91E85358}" type="datetimeFigureOut">
               <a:rPr lang="en-US" smtClean="0"/>
-              <a:t>10/10/19</a:t>
+              <a:t>1/8/20</a:t>
             </a:fld>
             <a:endParaRPr lang="en-US"/>
           </a:p>
@@ -3791,7 +3791,7 @@
           <a:p>
             <a:fld id="{A9942DAA-FFA8-C840-B5B2-5C2E91E85358}" type="datetimeFigureOut">
               <a:rPr lang="en-US" smtClean="0"/>
-              <a:t>10/10/19</a:t>
+              <a:t>1/8/20</a:t>
             </a:fld>
             <a:endParaRPr lang="en-US"/>
           </a:p>
@@ -4079,7 +4079,7 @@
           <a:p>
             <a:fld id="{A9942DAA-FFA8-C840-B5B2-5C2E91E85358}" type="datetimeFigureOut">
               <a:rPr lang="en-US" smtClean="0"/>
-              <a:t>10/10/19</a:t>
+              <a:t>1/8/20</a:t>
             </a:fld>
             <a:endParaRPr lang="en-US"/>
           </a:p>
@@ -4320,7 +4320,7 @@
           <a:p>
             <a:fld id="{A9942DAA-FFA8-C840-B5B2-5C2E91E85358}" type="datetimeFigureOut">
               <a:rPr lang="en-US" smtClean="0"/>
-              <a:t>10/10/19</a:t>
+              <a:t>1/8/20</a:t>
             </a:fld>
             <a:endParaRPr lang="en-US"/>
           </a:p>
@@ -8432,7 +8432,7 @@
                 <a:cs typeface="Calibri"/>
                 <a:sym typeface="Calibri"/>
               </a:rPr>
-              <a:t>Logistic Regression – Log Loss Error Function</a:t>
+              <a:t>Logistic Regression</a:t>
             </a:r>
             <a:endParaRPr sz="1800" dirty="0">
               <a:solidFill>
@@ -8717,10 +8717,127 @@
           </a:ln>
         </p:spPr>
       </p:pic>
+      <p:pic>
+        <p:nvPicPr>
+          <p:cNvPr id="2" name="Picture 1">
+            <a:extLst>
+              <a:ext uri="{FF2B5EF4-FFF2-40B4-BE49-F238E27FC236}">
+                <a16:creationId xmlns:a16="http://schemas.microsoft.com/office/drawing/2014/main" id="{DCD50082-63F2-2041-97F7-981BBB4B7163}"/>
+              </a:ext>
+            </a:extLst>
+          </p:cNvPr>
+          <p:cNvPicPr>
+            <a:picLocks noChangeAspect="1"/>
+          </p:cNvPicPr>
+          <p:nvPr/>
+        </p:nvPicPr>
+        <p:blipFill>
+          <a:blip r:embed="rId7" cstate="email">
+            <a:extLst>
+              <a:ext uri="{28A0092B-C50C-407E-A947-70E740481C1C}">
+                <a14:useLocalDpi xmlns:a14="http://schemas.microsoft.com/office/drawing/2010/main"/>
+              </a:ext>
+            </a:extLst>
+          </a:blip>
+          <a:stretch>
+            <a:fillRect/>
+          </a:stretch>
+        </p:blipFill>
+        <p:spPr>
+          <a:xfrm>
+            <a:off x="7867717" y="652363"/>
+            <a:ext cx="3822632" cy="2739212"/>
+          </a:xfrm>
+          <a:prstGeom prst="rect">
+            <a:avLst/>
+          </a:prstGeom>
+        </p:spPr>
+      </p:pic>
+      <p:sp>
+        <p:nvSpPr>
+          <p:cNvPr id="3" name="TextBox 2">
+            <a:extLst>
+              <a:ext uri="{FF2B5EF4-FFF2-40B4-BE49-F238E27FC236}">
+                <a16:creationId xmlns:a16="http://schemas.microsoft.com/office/drawing/2014/main" id="{2D6379A6-D0F0-1048-970D-47400CD24B22}"/>
+              </a:ext>
+            </a:extLst>
+          </p:cNvPr>
+          <p:cNvSpPr txBox="1"/>
+          <p:nvPr/>
+        </p:nvSpPr>
+        <p:spPr>
+          <a:xfrm>
+            <a:off x="8050924" y="178676"/>
+            <a:ext cx="3507413" cy="369332"/>
+          </a:xfrm>
+          <a:prstGeom prst="rect">
+            <a:avLst/>
+          </a:prstGeom>
+          <a:noFill/>
+        </p:spPr>
+        <p:txBody>
+          <a:bodyPr wrap="square" rtlCol="0">
+            <a:spAutoFit/>
+          </a:bodyPr>
+          <a:lstStyle/>
+          <a:p>
+            <a:r>
+              <a:rPr lang="en-US" dirty="0"/>
+              <a:t>Log-Loss error function is better:</a:t>
+            </a:r>
+          </a:p>
+        </p:txBody>
+      </p:sp>
+      <p:sp>
+        <p:nvSpPr>
+          <p:cNvPr id="4" name="Right Arrow 3">
+            <a:extLst>
+              <a:ext uri="{FF2B5EF4-FFF2-40B4-BE49-F238E27FC236}">
+                <a16:creationId xmlns:a16="http://schemas.microsoft.com/office/drawing/2014/main" id="{671B4982-3239-D746-9B9F-FBACD7DB2D04}"/>
+              </a:ext>
+            </a:extLst>
+          </p:cNvPr>
+          <p:cNvSpPr/>
+          <p:nvPr/>
+        </p:nvSpPr>
+        <p:spPr>
+          <a:xfrm>
+            <a:off x="6800194" y="1324682"/>
+            <a:ext cx="935420" cy="357351"/>
+          </a:xfrm>
+          <a:prstGeom prst="rightArrow">
+            <a:avLst/>
+          </a:prstGeom>
+        </p:spPr>
+        <p:style>
+          <a:lnRef idx="2">
+            <a:schemeClr val="accent1">
+              <a:shade val="50000"/>
+            </a:schemeClr>
+          </a:lnRef>
+          <a:fillRef idx="1">
+            <a:schemeClr val="accent1"/>
+          </a:fillRef>
+          <a:effectRef idx="0">
+            <a:schemeClr val="accent1"/>
+          </a:effectRef>
+          <a:fontRef idx="minor">
+            <a:schemeClr val="lt1"/>
+          </a:fontRef>
+        </p:style>
+        <p:txBody>
+          <a:bodyPr rtlCol="0" anchor="ctr"/>
+          <a:lstStyle/>
+          <a:p>
+            <a:pPr algn="ctr"/>
+            <a:endParaRPr lang="en-US"/>
+          </a:p>
+        </p:txBody>
+      </p:sp>
     </p:spTree>
     <p:extLst>
       <p:ext uri="{BB962C8B-B14F-4D97-AF65-F5344CB8AC3E}">
-        <p14:creationId xmlns:p14="http://schemas.microsoft.com/office/powerpoint/2010/main" val="986722743"/>
+        <p14:creationId xmlns:p14="http://schemas.microsoft.com/office/powerpoint/2010/main" val="591702088"/>
       </p:ext>
     </p:extLst>
   </p:cSld>
@@ -9932,7 +10049,7 @@
                   <a:srgbClr val="0070C0"/>
                 </a:solidFill>
               </a:rPr>
-              <a:t>-ln(1-0.047)   = ~  3.055</a:t>
+              <a:t>-ln(1-0.047)   = ~ 0.048</a:t>
             </a:r>
           </a:p>
         </p:txBody>
@@ -9971,7 +10088,7 @@
                   <a:srgbClr val="0070C0"/>
                 </a:solidFill>
               </a:rPr>
-              <a:t>-ln(1-0.006)   = ~  5.055</a:t>
+              <a:t>-ln(1-0.006)   = ~  0.006</a:t>
             </a:r>
           </a:p>
         </p:txBody>
@@ -10125,7 +10242,7 @@
           <a:p>
             <a:r>
               <a:rPr lang="en-US" dirty="0"/>
-              <a:t>8.165</a:t>
+              <a:t>0.109</a:t>
             </a:r>
           </a:p>
         </p:txBody>
@@ -10301,7 +10418,7 @@
     </p:spTree>
     <p:extLst>
       <p:ext uri="{BB962C8B-B14F-4D97-AF65-F5344CB8AC3E}">
-        <p14:creationId xmlns:p14="http://schemas.microsoft.com/office/powerpoint/2010/main" val="2145058635"/>
+        <p14:creationId xmlns:p14="http://schemas.microsoft.com/office/powerpoint/2010/main" val="3194623166"/>
       </p:ext>
     </p:extLst>
   </p:cSld>

</xml_diff>